<commit_message>
Stage 8 review fixes: E-023
</commit_message>
<xml_diff>
--- a/output/archive/WestravelleData/Quality/Training/Reference_Copies/Copy of PLATE_ACCEPTANCE_WA_Rev01.pptx
+++ b/output/archive/WestravelleData/Quality/Training/Reference_Copies/Copy of PLATE_ACCEPTANCE_WA_Rev01.pptx
@@ -6,7 +6,7 @@
   </p:sldMasterIdLst>
   <p:sldIdLst>
     <p:sldId id="256" r:id="rId7"/>
-    <p:sldId id="257" r:id="rId8"/>
+    <p:sldId id="257" r:id="rId9"/>
     <p:sldId id="258" r:id="rId10"/>
     <p:sldId id="259" r:id="rId11"/>
     <p:sldId id="260" r:id="rId12"/>
@@ -507,7 +507,7 @@
           <a:lstStyle/>
           <a:p>
             <a:r>
-              <a:t>Trainees often confuse the two. Walk through the difference on slide 5 before they start on the bench.</a:t>
+              <a:t>Local cover note — Carla Smith: retained as a training reference. Screening plate acceptance illustrates a control-based reporting gate; apply Westravelle system suitability requirements to chromatographic sequences. This copy does not authorise a local screening procedure.</a:t>
             </a:r>
           </a:p>
         </p:txBody>
@@ -577,7 +577,7 @@
           <a:lstStyle/>
           <a:p>
             <a:r>
-              <a:t>The window values live in the current protocol, not in this deck. Quote the protocol revision on the batch card.</a:t>
+              <a:t>Local comparison added for Westravelle training; source screening terminology retained on the following slides.</a:t>
             </a:r>
           </a:p>
         </p:txBody>
@@ -647,7 +647,7 @@
           <a:lstStyle/>
           <a:p>
             <a:r>
-              <a:t>Do not average the rejected plate into the repeat. Keep both on file.</a:t>
+              <a:t>Acceptance windows and any permitted exclusions belong to the approved protocol. Record its revision with the plate record.</a:t>
             </a:r>
           </a:p>
         </p:txBody>
@@ -717,7 +717,147 @@
           <a:lstStyle/>
           <a:p>
             <a:r>
-              <a:t>Saira Mahmood and Mark Campbell have agreed the wording of this slide. Check the current version of the protocol before use.</a:t>
+              <a:t>Brindlewythe Biosciences training schematic; not a well-position map. Control and replicate positions follow the approved protocol. Do not move or exclude controls to rescue a failed plate. Evaluate spatial effects using the acquired data.</a:t>
+            </a:r>
+          </a:p>
+        </p:txBody>
+      </p:sp>
+      <p:sp>
+        <p:nvSpPr>
+          <p:cNvPr id="4" name="Slide Number Placeholder 3"/>
+          <p:cNvSpPr>
+            <a:spLocks noGrp="1"/>
+          </p:cNvSpPr>
+          <p:nvPr>
+            <p:ph type="sldNum" idx="5" sz="quarter"/>
+          </p:nvPr>
+        </p:nvSpPr>
+        <p:spPr/>
+      </p:sp>
+    </p:spTree>
+  </p:cSld>
+  <p:clrMapOvr>
+    <a:masterClrMapping/>
+  </p:clrMapOvr>
+</p:notes>
+</file>
+
+<file path=ppt/notesSlides/notesSlide5.xml><?xml version="1.0" encoding="utf-8"?>
+<p:notes xmlns:a="http://schemas.openxmlformats.org/drawingml/2006/main" xmlns:p="http://schemas.openxmlformats.org/presentationml/2006/main" xmlns:r="http://schemas.openxmlformats.org/officeDocument/2006/relationships">
+  <p:cSld>
+    <p:spTree>
+      <p:nvGrpSpPr>
+        <p:cNvPr id="1" name=""/>
+        <p:cNvGrpSpPr/>
+        <p:nvPr/>
+      </p:nvGrpSpPr>
+      <p:grpSpPr>
+        <a:xfrm>
+          <a:off x="0" y="0"/>
+          <a:ext cx="0" cy="0"/>
+          <a:chOff x="0" y="0"/>
+          <a:chExt cx="0" cy="0"/>
+        </a:xfrm>
+      </p:grpSpPr>
+      <p:sp>
+        <p:nvSpPr>
+          <p:cNvPr id="2" name="Slide Image Placeholder 1"/>
+          <p:cNvSpPr>
+            <a:spLocks noGrp="1"/>
+          </p:cNvSpPr>
+          <p:nvPr>
+            <p:ph type="sldImg" idx="2"/>
+          </p:nvPr>
+        </p:nvSpPr>
+        <p:spPr/>
+      </p:sp>
+      <p:sp>
+        <p:nvSpPr>
+          <p:cNvPr id="3" name="Notes Placeholder 2"/>
+          <p:cNvSpPr>
+            <a:spLocks noGrp="1"/>
+          </p:cNvSpPr>
+          <p:nvPr>
+            <p:ph type="body" idx="3" sz="quarter"/>
+          </p:nvPr>
+        </p:nvSpPr>
+        <p:spPr/>
+        <p:txBody>
+          <a:bodyPr/>
+          <a:lstStyle/>
+          <a:p>
+            <a:r>
+              <a:t>Do not average rejected results into accepted repeat results. This reference copy sets no repeat allowance or escalation count.</a:t>
+            </a:r>
+          </a:p>
+        </p:txBody>
+      </p:sp>
+      <p:sp>
+        <p:nvSpPr>
+          <p:cNvPr id="4" name="Slide Number Placeholder 3"/>
+          <p:cNvSpPr>
+            <a:spLocks noGrp="1"/>
+          </p:cNvSpPr>
+          <p:nvPr>
+            <p:ph type="sldNum" idx="5" sz="quarter"/>
+          </p:nvPr>
+        </p:nvSpPr>
+        <p:spPr/>
+      </p:sp>
+    </p:spTree>
+  </p:cSld>
+  <p:clrMapOvr>
+    <a:masterClrMapping/>
+  </p:clrMapOvr>
+</p:notes>
+</file>
+
+<file path=ppt/notesSlides/notesSlide6.xml><?xml version="1.0" encoding="utf-8"?>
+<p:notes xmlns:a="http://schemas.openxmlformats.org/drawingml/2006/main" xmlns:p="http://schemas.openxmlformats.org/presentationml/2006/main" xmlns:r="http://schemas.openxmlformats.org/officeDocument/2006/relationships">
+  <p:cSld>
+    <p:spTree>
+      <p:nvGrpSpPr>
+        <p:cNvPr id="1" name=""/>
+        <p:cNvGrpSpPr/>
+        <p:nvPr/>
+      </p:nvGrpSpPr>
+      <p:grpSpPr>
+        <a:xfrm>
+          <a:off x="0" y="0"/>
+          <a:ext cx="0" cy="0"/>
+          <a:chOff x="0" y="0"/>
+          <a:chExt cx="0" cy="0"/>
+        </a:xfrm>
+      </p:grpSpPr>
+      <p:sp>
+        <p:nvSpPr>
+          <p:cNvPr id="2" name="Slide Image Placeholder 1"/>
+          <p:cNvSpPr>
+            <a:spLocks noGrp="1"/>
+          </p:cNvSpPr>
+          <p:nvPr>
+            <p:ph type="sldImg" idx="2"/>
+          </p:nvPr>
+        </p:nvSpPr>
+        <p:spPr/>
+      </p:sp>
+      <p:sp>
+        <p:nvSpPr>
+          <p:cNvPr id="3" name="Notes Placeholder 2"/>
+          <p:cNvSpPr>
+            <a:spLocks noGrp="1"/>
+          </p:cNvSpPr>
+          <p:nvPr>
+            <p:ph type="body" idx="3" sz="quarter"/>
+          </p:nvPr>
+        </p:nvSpPr>
+        <p:spPr/>
+        <p:txBody>
+          <a:bodyPr/>
+          <a:lstStyle/>
+          <a:p>
+            <a:r>
+              <a:t>Local comparison: plate records carry screening acceptance decisions; sequence sheets carry chromatographic system suitability entries. A pass in either workflow does not establish acceptance in the other. Review and sign-off follow the applicable approved procedure.</a:t>
             </a:r>
           </a:p>
         </p:txBody>
@@ -3825,7 +3965,7 @@
                 </a:solidFill>
                 <a:latin typeface="Arial"/>
               </a:rPr>
-              <a:t>Westravelle Analytical Ltd, a Tarnovell company | QA training | Reference copy, September 2024</a:t>
+              <a:t>Westravelle Analytical Ltd, a Tarnovell company | 19 Sep 2024 | Copy of Brindlewythe Biosciences training deck</a:t>
             </a:r>
           </a:p>
         </p:txBody>
@@ -3908,7 +4048,7 @@
               <a:rPr sz="2000">
                 <a:latin typeface="Arial"/>
               </a:rPr>
-              <a:t>Plate acceptance decides whether a screening plate can be used for reporting at all</a:t>
+              <a:t>Brindlewythe Biosciences reference: plate acceptance determines whether acquired screening data are suitable for interpretation and reporting</a:t>
             </a:r>
           </a:p>
           <a:p>
@@ -3917,7 +4057,7 @@
               <a:rPr sz="2000">
                 <a:latin typeface="Arial"/>
               </a:rPr>
-              <a:t>It is checked before any compound well is read</a:t>
+              <a:t>Confirm the plate map and required controls before acquisition; evaluate control signals and plate statistics after acquisition</a:t>
             </a:r>
           </a:p>
           <a:p>
@@ -3926,7 +4066,7 @@
               <a:rPr sz="2000">
                 <a:latin typeface="Arial"/>
               </a:rPr>
-              <a:t>It is separate from system suitability, which applies to the chromatographic runs in the stability programme</a:t>
+              <a:t>Westravelle comparison: system suitability establishes whether a chromatographic sequence meets its method criteria</a:t>
             </a:r>
           </a:p>
           <a:p>
@@ -3935,7 +4075,7 @@
               <a:rPr sz="1700">
                 <a:latin typeface="Arial"/>
               </a:rPr>
-              <a:t>Both are recorded on the batch card; neither replaces the other</a:t>
+              <a:t>Use the approved protocol or method for the criteria, documentation and reporting decision; the two checks are not interchangeable</a:t>
             </a:r>
           </a:p>
         </p:txBody>
@@ -4227,7 +4367,7 @@
                         <a:rPr sz="1400">
                           <a:latin typeface="Arial"/>
                         </a:rPr>
-                        <a:t>Each control type is in the positions set in the plate map</a:t>
+                        <a:t>Required control types and positions agree with the approved plate map</a:t>
                       </a:r>
                     </a:p>
                   </a:txBody>
@@ -4242,7 +4382,7 @@
                         <a:rPr sz="1400">
                           <a:latin typeface="Arial"/>
                         </a:rPr>
-                        <a:t>Do not read; raise a deviation note</a:t>
+                        <a:t>Hold reporting; document the discrepancy and assess under the protocol</a:t>
                       </a:r>
                     </a:p>
                   </a:txBody>
@@ -4274,7 +4414,7 @@
                         <a:rPr sz="1400">
                           <a:latin typeface="Arial"/>
                         </a:rPr>
-                        <a:t>Signal sits inside the window set in the protocol</a:t>
+                        <a:t>Response meets the protocol-defined window</a:t>
                       </a:r>
                     </a:p>
                   </a:txBody>
@@ -4289,7 +4429,7 @@
                         <a:rPr sz="1400">
                           <a:latin typeface="Arial"/>
                         </a:rPr>
-                        <a:t>Do not read; repeat the plate once</a:t>
+                        <a:t>Reject if the acceptance criterion fails; investigate before repeating</a:t>
                       </a:r>
                     </a:p>
                   </a:txBody>
@@ -4321,7 +4461,7 @@
                         <a:rPr sz="1400">
                           <a:latin typeface="Arial"/>
                         </a:rPr>
-                        <a:t>Background is low and flat across the plate</a:t>
+                        <a:t>Background and variability meet the protocol criteria</a:t>
                       </a:r>
                     </a:p>
                   </a:txBody>
@@ -4336,7 +4476,7 @@
                         <a:rPr sz="1400">
                           <a:latin typeface="Arial"/>
                         </a:rPr>
-                        <a:t>Check reagent make-up and washing before any repeat</a:t>
+                        <a:t>Hold reporting and investigate the failure</a:t>
                       </a:r>
                     </a:p>
                   </a:txBody>
@@ -4368,7 +4508,7 @@
                         <a:rPr sz="1400">
                           <a:latin typeface="Arial"/>
                         </a:rPr>
-                        <a:t>No drift from the outer rows and columns that is wider than the protocol allows</a:t>
+                        <a:t>Spatial effects assessed against the protocol criteria</a:t>
                       </a:r>
                     </a:p>
                   </a:txBody>
@@ -4383,7 +4523,7 @@
                         <a:rPr sz="1400">
                           <a:latin typeface="Arial"/>
                         </a:rPr>
-                        <a:t>Note on the batch card; read only if the protocol permits</a:t>
+                        <a:t>Document and apply the pre-defined acceptance rule; no retrospective rescue</a:t>
                       </a:r>
                     </a:p>
                   </a:txBody>
@@ -4400,7 +4540,7 @@
                         <a:rPr sz="1400">
                           <a:latin typeface="Arial"/>
                         </a:rPr>
-                        <a:t>Z' for the plate</a:t>
+                        <a:t>Z′ for the plate</a:t>
                       </a:r>
                     </a:p>
                   </a:txBody>
@@ -4415,7 +4555,7 @@
                         <a:rPr sz="1400">
                           <a:latin typeface="Arial"/>
                         </a:rPr>
-                        <a:t>Calculated from the control wells as stated in the protocol</a:t>
+                        <a:t>Calculated from acquired control-well signals as stated in the protocol</a:t>
                       </a:r>
                     </a:p>
                   </a:txBody>
@@ -4430,7 +4570,7 @@
                         <a:rPr sz="1400">
                           <a:latin typeface="Arial"/>
                         </a:rPr>
-                        <a:t>Plate rejected; no partial reporting</a:t>
+                        <a:t>Apply the protocol criterion; retain rejected data without reporting them as accepted results</a:t>
                       </a:r>
                     </a:p>
                   </a:txBody>
@@ -4521,123 +4661,14 @@
                 </a:solidFill>
                 <a:latin typeface="Arial"/>
               </a:rPr>
-              <a:t>3 Controls and layout</a:t>
-            </a:r>
-          </a:p>
-        </p:txBody>
-      </p:sp>
-      <p:sp>
-        <p:nvSpPr>
-          <p:cNvPr id="3" name="Content Placeholder 2"/>
-          <p:cNvSpPr>
-            <a:spLocks noGrp="1"/>
-          </p:cNvSpPr>
-          <p:nvPr>
-            <p:ph idx="1" sz="half"/>
-          </p:nvPr>
-        </p:nvSpPr>
-        <p:spPr>
-          <a:xfrm>
-            <a:off x="457200" y="1280160"/>
-            <a:ext cx="5547207" cy="4937760"/>
-          </a:xfrm>
-        </p:spPr>
-        <p:txBody>
-          <a:bodyPr wrap="square">
-            <a:noAutofit/>
-          </a:bodyPr>
-          <a:lstStyle/>
-          <a:p>
-            <a:pPr/>
-            <a:r>
-              <a:rPr sz="1800">
-                <a:latin typeface="Arial"/>
-              </a:rPr>
-              <a:t>Controls go in the positions shown on the plate map</a:t>
-            </a:r>
-          </a:p>
-          <a:p>
-            <a:pPr/>
-            <a:r>
-              <a:rPr sz="1800">
-                <a:latin typeface="Arial"/>
-              </a:rPr>
-              <a:t>Do not move a control to rescue a plate</a:t>
-            </a:r>
-          </a:p>
-          <a:p>
-            <a:pPr/>
-            <a:r>
-              <a:rPr sz="1800">
-                <a:latin typeface="Arial"/>
-              </a:rPr>
-              <a:t>Plate map is printed and filed with the batch card</a:t>
-            </a:r>
-          </a:p>
-          <a:p>
-            <a:pPr/>
-            <a:r>
-              <a:rPr sz="1800">
-                <a:latin typeface="Arial"/>
-              </a:rPr>
-              <a:t>Replicate wells follow the layout in the protocol</a:t>
-            </a:r>
-          </a:p>
-        </p:txBody>
-      </p:sp>
-      <p:sp>
-        <p:nvSpPr>
-          <p:cNvPr id="4" name="Content Placeholder 3"/>
-          <p:cNvSpPr>
-            <a:spLocks noGrp="1"/>
-          </p:cNvSpPr>
-          <p:nvPr>
-            <p:ph idx="2" sz="half"/>
-          </p:nvPr>
-        </p:nvSpPr>
-        <p:spPr>
-          <a:xfrm>
-            <a:off x="6187287" y="1280160"/>
-            <a:ext cx="5547207" cy="4937760"/>
-          </a:xfrm>
-        </p:spPr>
-        <p:txBody>
-          <a:bodyPr wrap="square">
-            <a:noAutofit/>
-          </a:bodyPr>
-          <a:lstStyle/>
-          <a:p>
-            <a:pPr/>
-            <a:r>
-              <a:rPr sz="1800">
-                <a:latin typeface="Arial"/>
-              </a:rPr>
-              <a:t>Edge effects are looked at on every plate, not just new ones</a:t>
-            </a:r>
-          </a:p>
-          <a:p>
-            <a:pPr/>
-            <a:r>
-              <a:rPr sz="1800">
-                <a:latin typeface="Arial"/>
-              </a:rPr>
-              <a:t>Column 1 and 24 are used for controls only where the protocol says so</a:t>
-            </a:r>
-          </a:p>
-          <a:p>
-            <a:pPr/>
-            <a:r>
-              <a:rPr sz="1800">
-                <a:latin typeface="Arial"/>
-              </a:rPr>
-              <a:t>A plate with a missing control is not partly read</a:t>
-            </a:r>
-          </a:p>
-        </p:txBody>
-      </p:sp>
-      <p:sp>
-        <p:nvSpPr>
-          <p:cNvPr id="5" name="Rectangle 4"/>
+              <a:t>3 Screening-control layout — retained reference diagram</a:t>
+            </a:r>
+          </a:p>
+        </p:txBody>
+      </p:sp>
+      <p:sp>
+        <p:nvSpPr>
+          <p:cNvPr id="3" name="Rectangle 2"/>
           <p:cNvSpPr/>
           <p:nvPr/>
         </p:nvSpPr>
@@ -4678,9 +4709,33 @@
           </a:p>
         </p:txBody>
       </p:sp>
-      <p:sp>
-        <p:nvSpPr>
-          <p:cNvPr id="6" name="TextBox 5"/>
+      <p:pic>
+        <p:nvPicPr>
+          <p:cNvPr id="4" name="Picture 3" descr="image.png"/>
+          <p:cNvPicPr>
+            <a:picLocks noChangeAspect="1"/>
+          </p:cNvPicPr>
+          <p:nvPr/>
+        </p:nvPicPr>
+        <p:blipFill>
+          <a:blip r:embed="rId2"/>
+          <a:stretch>
+            <a:fillRect/>
+          </a:stretch>
+        </p:blipFill>
+        <p:spPr>
+          <a:xfrm>
+            <a:off x="1023820" y="1280160"/>
+            <a:ext cx="10144055" cy="5029199"/>
+          </a:xfrm>
+          <a:prstGeom prst="rect">
+            <a:avLst/>
+          </a:prstGeom>
+        </p:spPr>
+      </p:pic>
+      <p:sp>
+        <p:nvSpPr>
+          <p:cNvPr id="5" name="TextBox 4"/>
           <p:cNvSpPr txBox="1"/>
           <p:nvPr/>
         </p:nvSpPr>
@@ -4790,7 +4845,7 @@
               <a:rPr sz="2000">
                 <a:latin typeface="Arial"/>
               </a:rPr>
-              <a:t>A failed plate is marked on the batch card and not deleted</a:t>
+              <a:t>Retain the failed plate data, plate map and acceptance assessment in the screening record</a:t>
             </a:r>
           </a:p>
           <a:p>
@@ -4799,7 +4854,7 @@
               <a:rPr sz="2000">
                 <a:latin typeface="Arial"/>
               </a:rPr>
-              <a:t>Raise a deviation note for every rejected plate, giving the plate ID and the check that failed</a:t>
+              <a:t>Document the plate identifier, failed criterion and investigation in the required deviation record</a:t>
             </a:r>
           </a:p>
           <a:p>
@@ -4808,7 +4863,7 @@
               <a:rPr sz="2000">
                 <a:latin typeface="Arial"/>
               </a:rPr>
-              <a:t>One repeat is allowed where the protocol allows it; the repeat is recorded as a new plate</a:t>
+              <a:t>Repeat only as authorised by the approved protocol or documented investigation; preserve the link to the original plate</a:t>
             </a:r>
           </a:p>
           <a:p>
@@ -4817,7 +4872,7 @@
               <a:rPr sz="2000">
                 <a:latin typeface="Arial"/>
               </a:rPr>
-              <a:t>Two failures on the same compound set go to the QC method validation lead before any further work</a:t>
+              <a:t>Escalate recurrent failures to the responsible scientific and quality reviewers before further work</a:t>
             </a:r>
           </a:p>
         </p:txBody>
@@ -4952,75 +5007,7 @@
       </p:sp>
       <p:sp>
         <p:nvSpPr>
-          <p:cNvPr id="3" name="Content Placeholder 2"/>
-          <p:cNvSpPr>
-            <a:spLocks noGrp="1"/>
-          </p:cNvSpPr>
-          <p:nvPr>
-            <p:ph idx="1"/>
-          </p:nvPr>
-        </p:nvSpPr>
-        <p:spPr>
-          <a:xfrm>
-            <a:off x="457200" y="1280160"/>
-            <a:ext cx="11277295" cy="4937760"/>
-          </a:xfrm>
-        </p:spPr>
-        <p:txBody>
-          <a:bodyPr wrap="square">
-            <a:noAutofit/>
-          </a:bodyPr>
-          <a:lstStyle/>
-          <a:p>
-            <a:pPr/>
-            <a:r>
-              <a:rPr sz="2000">
-                <a:latin typeface="Arial"/>
-              </a:rPr>
-              <a:t>Plate acceptance is applied to each screening plate before reading</a:t>
-            </a:r>
-          </a:p>
-          <a:p>
-            <a:pPr/>
-            <a:r>
-              <a:rPr sz="2000">
-                <a:latin typeface="Arial"/>
-              </a:rPr>
-              <a:t>System suitability is applied to each chromatographic sequence before sample results are released</a:t>
-            </a:r>
-          </a:p>
-          <a:p>
-            <a:pPr/>
-            <a:r>
-              <a:rPr sz="2000">
-                <a:latin typeface="Arial"/>
-              </a:rPr>
-              <a:t>A passing plate does not show that the instrument was suitable on the day, and a passing sequence does not accept a plate</a:t>
-            </a:r>
-          </a:p>
-          <a:p>
-            <a:pPr lvl="1"/>
-            <a:r>
-              <a:rPr sz="1700">
-                <a:latin typeface="Arial"/>
-              </a:rPr>
-              <a:t>Sequence sheets carry the system suitability entries; plate maps carry the plate acceptance entries</a:t>
-            </a:r>
-          </a:p>
-          <a:p>
-            <a:pPr/>
-            <a:r>
-              <a:rPr sz="2000">
-                <a:latin typeface="Arial"/>
-              </a:rPr>
-              <a:t>Both are signed by the analyst and checked by a second person before the batch card is closed</a:t>
-            </a:r>
-          </a:p>
-        </p:txBody>
-      </p:sp>
-      <p:sp>
-        <p:nvSpPr>
-          <p:cNvPr id="4" name="Rectangle 3"/>
+          <p:cNvPr id="3" name="Rectangle 2"/>
           <p:cNvSpPr/>
           <p:nvPr/>
         </p:nvSpPr>
@@ -5061,6 +5048,30 @@
           </a:p>
         </p:txBody>
       </p:sp>
+      <p:pic>
+        <p:nvPicPr>
+          <p:cNvPr id="4" name="Picture 3" descr="image.png"/>
+          <p:cNvPicPr>
+            <a:picLocks noChangeAspect="1"/>
+          </p:cNvPicPr>
+          <p:nvPr/>
+        </p:nvPicPr>
+        <p:blipFill>
+          <a:blip r:embed="rId2"/>
+          <a:stretch>
+            <a:fillRect/>
+          </a:stretch>
+        </p:blipFill>
+        <p:spPr>
+          <a:xfrm>
+            <a:off x="576145" y="1280160"/>
+            <a:ext cx="11039404" cy="5029199"/>
+          </a:xfrm>
+          <a:prstGeom prst="rect">
+            <a:avLst/>
+          </a:prstGeom>
+        </p:spPr>
+      </p:pic>
       <p:sp>
         <p:nvSpPr>
           <p:cNvPr id="5" name="TextBox 4"/>

</xml_diff>